<commit_message>
Add research paper and literature review deliverables
</commit_message>
<xml_diff>
--- a/reports/presentation.pptx
+++ b/reports/presentation.pptx
@@ -123,14 +123,14 @@
   <p:extLst>
     <p:ext uri="{521415D9-36F7-43E2-AB2F-B90AF26B5E84}">
       <p14:sectionLst xmlns:p14="http://schemas.microsoft.com/office/powerpoint/2010/main">
-        <p14:section name="Introduction" id="{9c92460e-88ff-a07c-f882-16db81ead928}">
+        <p14:section name="Introduction" id="{e2e3db72-1a99-cf47-42ef-9258dd88fc0a}">
           <p14:sldIdLst>
             <p14:sldId id="256"/>
             <p14:sldId id="257"/>
             <p14:sldId id="258"/>
           </p14:sldIdLst>
         </p14:section>
-        <p14:section name="Method" id="{b6ba7e9e-9643-06ac-cabc-11d48fafd833}">
+        <p14:section name="Method" id="{bcdde2bd-f364-e355-677b-b63d67ea0947}">
           <p14:sldIdLst>
             <p14:sldId id="259"/>
             <p14:sldId id="260"/>
@@ -138,7 +138,7 @@
             <p14:sldId id="262"/>
           </p14:sldIdLst>
         </p14:section>
-        <p14:section name="Results" id="{dfc55e72-61c9-e235-3e13-336cf210d180}">
+        <p14:section name="Results" id="{535e0380-c0ab-3d45-91f5-72a0d36232d2}">
           <p14:sldIdLst>
             <p14:sldId id="263"/>
             <p14:sldId id="264"/>
@@ -147,7 +147,7 @@
             <p14:sldId id="267"/>
           </p14:sldIdLst>
         </p14:section>
-        <p14:section name="Status and outlook" id="{0562ae02-9157-2818-4642-3ac3fe96d3cc}">
+        <p14:section name="Status and outlook" id="{ab4a9508-7e73-c750-f52e-c447be3d5e48}">
           <p14:sldIdLst>
             <p14:sldId id="268"/>
             <p14:sldId id="269"/>
@@ -5693,7 +5693,7 @@
                   <a:schemeClr val="bg2"/>
                 </a:solidFill>
               </a:rPr>
-              <a:t>Project review · October 2026</a:t>
+              <a:t>Project review</a:t>
             </a:r>
             <a:endParaRPr lang="en-US" sz="1400" dirty="0"/>
           </a:p>

</xml_diff>